<commit_message>
Stop requiring UserSettings; remove it from all examples
Student submissions need only Assets, Packages and ProjectSettings.
Fix the EX1-EX3 handouts, the Module-1 notes and the Module-1 summary
slides, untrack UserSettings in all 25 example projects, and add it
to .gitignore.

Co-Authored-By: Claude Opus 5.5 <noreply@anthropic.com>
</commit_message>
<xml_diff>
--- a/Classnotes/Module-1/Module-1-Summary.pptx
+++ b/Classnotes/Module-1/Module-1-Summary.pptx
@@ -864,7 +864,7 @@
           <a:p>
             <a:r>
               <a:rPr lang="en-US" dirty="0"/>
-              <a:t>Before opening Unity, look at 1.1.BasicSimpleProject in File Explorer: Assets, Packages, ProjectSettings, UserSettings (and EXE, the build). Then open it in Unity and watch Library, Logs and Temp appear. None of those are needed to save your work. Before submitting, delete them; and always keep a backup copy so you can recover if you delete the wrong thing. At minimum, fork the course repository so you see updates.</a:t>
+              <a:t>Before opening Unity, look at 1.1.BasicSimpleProject in File Explorer: Assets, Packages, ProjectSettings (and EXE, the build). Then open it in Unity and watch Library, Logs, Temp and UserSettings appear. None of those are needed to save your work. Before submitting, delete them; and always keep a backup copy so you can recover if you delete the wrong thing. At minimum, fork the course repository so you see updates.</a:t>
             </a:r>
             <a:endParaRPr lang="en-US" dirty="0"/>
           </a:p>
@@ -4504,7 +4504,7 @@
                 <a:ea typeface="Arial" pitchFamily="34" charset="-122"/>
                 <a:cs typeface="Arial" pitchFamily="34" charset="-120"/>
               </a:rPr>
-              <a:t>Save four folders: </a:t>
+              <a:t>Save three folders: </a:t>
             </a:r>
             <a:r>
               <a:rPr lang="en-US" sz="1500" b="1" dirty="0">
@@ -4515,7 +4515,7 @@
                 <a:ea typeface="Arial" pitchFamily="34" charset="-122"/>
                 <a:cs typeface="Arial" pitchFamily="34" charset="-120"/>
               </a:rPr>
-              <a:t>Assets, Packages, ProjectSettings, UserSettings</a:t>
+              <a:t>Assets, Packages, ProjectSettings</a:t>
             </a:r>
             <a:r>
               <a:rPr lang="en-US" sz="1500" dirty="0">
@@ -5443,7 +5443,7 @@
                 <a:ea typeface="Arial" pitchFamily="34" charset="-122"/>
                 <a:cs typeface="Arial" pitchFamily="34" charset="-120"/>
               </a:rPr>
-              <a:t>A Unity project needs only four folders</a:t>
+              <a:t>A Unity project needs only three folders</a:t>
             </a:r>
             <a:endParaRPr lang="en-US" sz="3200" dirty="0"/>
           </a:p>
@@ -5666,54 +5666,6 @@
       </p:sp>
       <p:sp>
         <p:nvSpPr>
-          <p:cNvPr id="9" name="Text 7"/>
-          <p:cNvSpPr/>
-          <p:nvPr/>
-        </p:nvSpPr>
-        <p:spPr>
-          <a:xfrm>
-            <a:off x="1073150" y="3176141"/>
-            <a:ext cx="1742678" cy="411460"/>
-          </a:xfrm>
-          <a:prstGeom prst="roundRect">
-            <a:avLst>
-              <a:gd name="adj" fmla="val 18519"/>
-            </a:avLst>
-          </a:prstGeom>
-          <a:solidFill>
-            <a:srgbClr val="E8F0FD"/>
-          </a:solidFill>
-          <a:ln/>
-        </p:spPr>
-        <p:txBody>
-          <a:bodyPr wrap="none" lIns="0" tIns="0" rIns="0" bIns="0" rtlCol="0" anchor="ctr">
-            <a:normAutofit/>
-          </a:bodyPr>
-          <a:lstStyle/>
-          <a:p>
-            <a:pPr algn="ctr" indent="0" marL="0">
-              <a:lnSpc>
-                <a:spcPts val="2240"/>
-              </a:lnSpc>
-              <a:buNone/>
-            </a:pPr>
-            <a:r>
-              <a:rPr lang="en-US" sz="1600" dirty="0">
-                <a:solidFill>
-                  <a:srgbClr val="1F4FA8"/>
-                </a:solidFill>
-                <a:latin typeface="Courier New" pitchFamily="49" charset="0"/>
-                <a:ea typeface="Courier New" pitchFamily="49" charset="-122"/>
-                <a:cs typeface="Courier New" pitchFamily="49" charset="-120"/>
-              </a:rPr>
-              <a:t>UserSettings</a:t>
-            </a:r>
-            <a:endParaRPr lang="en-US" sz="1600" dirty="0"/>
-          </a:p>
-        </p:txBody>
-      </p:sp>
-      <p:sp>
-        <p:nvSpPr>
           <p:cNvPr id="10" name="Text 8"/>
           <p:cNvSpPr/>
           <p:nvPr/>
@@ -5821,7 +5773,7 @@
                 <a:ea typeface="Arial" pitchFamily="34" charset="-122"/>
                 <a:cs typeface="Arial" pitchFamily="34" charset="-120"/>
               </a:rPr>
-              <a:t>Skip: Unity regenerates these</a:t>
+              <a:t>Skip: not needed, or Unity regenerates these</a:t>
             </a:r>
             <a:endParaRPr lang="en-US" sz="1800" dirty="0"/>
           </a:p>
@@ -6158,6 +6110,54 @@
                 <a:cs typeface="Courier New" pitchFamily="49" charset="-120"/>
               </a:rPr>
               <a:t>.vscode</a:t>
+            </a:r>
+            <a:endParaRPr lang="en-US" sz="1600" dirty="0"/>
+          </a:p>
+        </p:txBody>
+      </p:sp>
+      <p:sp>
+        <p:nvSpPr>
+          <p:cNvPr id="9" name="Text 7"/>
+          <p:cNvSpPr/>
+          <p:nvPr/>
+        </p:nvSpPr>
+        <p:spPr>
+          <a:xfrm>
+            <a:off x="9551988" y="3176141"/>
+            <a:ext cx="1742678" cy="411460"/>
+          </a:xfrm>
+          <a:prstGeom prst="roundRect">
+            <a:avLst>
+              <a:gd name="adj" fmla="val 18519"/>
+            </a:avLst>
+          </a:prstGeom>
+          <a:solidFill>
+            <a:srgbClr val="ECEEF3"/>
+          </a:solidFill>
+          <a:ln/>
+        </p:spPr>
+        <p:txBody>
+          <a:bodyPr wrap="none" lIns="0" tIns="0" rIns="0" bIns="0" rtlCol="0" anchor="ctr">
+            <a:normAutofit/>
+          </a:bodyPr>
+          <a:lstStyle/>
+          <a:p>
+            <a:pPr algn="ctr" indent="0" marL="0">
+              <a:lnSpc>
+                <a:spcPts val="2240"/>
+              </a:lnSpc>
+              <a:buNone/>
+            </a:pPr>
+            <a:r>
+              <a:rPr lang="en-US" sz="1600" dirty="0">
+                <a:solidFill>
+                  <a:srgbClr val="4F586A"/>
+                </a:solidFill>
+                <a:latin typeface="Courier New" pitchFamily="49" charset="0"/>
+                <a:ea typeface="Courier New" pitchFamily="49" charset="-122"/>
+                <a:cs typeface="Courier New" pitchFamily="49" charset="-120"/>
+              </a:rPr>
+              <a:t>UserSettings</a:t>
             </a:r>
             <a:endParaRPr lang="en-US" sz="1600" dirty="0"/>
           </a:p>

</xml_diff>